<commit_message>
Switch deck to a two-group design: with vs without gamification
Co-Authored-By: Claude Opus 5.5 <noreply@anthropic.com>
Claude-Session: https://claude.ai/code/session_01KouW72fBMSCT3ro1ARBkSw
</commit_message>
<xml_diff>
--- a/reports/Asakusa_progress_report.pptx
+++ b/reports/Asakusa_progress_report.pptx
@@ -10,6 +10,7 @@
   <p:sldIdLst>
     <p:sldId id="256" r:id="rId6"/>
     <p:sldId id="257" r:id="rId7"/>
+    <p:sldId id="267" r:id="rId17"/>
     <p:sldId id="266" r:id="rId16"/>
     <p:sldId id="265" r:id="rId15"/>
     <p:sldId id="264" r:id="rId14"/>
@@ -8598,6 +8599,816 @@
                 <a:cs typeface="Arial"/>
                 <a:sym typeface="Arial"/>
               </a:rPr>
+              <a:t>Hypotheses and measures</a:t>
+            </a:r>
+            <a:endParaRPr/>
+          </a:p>
+        </p:txBody>
+      </p:sp>
+      <p:graphicFrame>
+        <p:nvGraphicFramePr>
+          <p:cNvPr id="53" name="Table 52"/>
+          <p:cNvGraphicFramePr>
+            <a:graphicFrameLocks noGrp="1"/>
+          </p:cNvGraphicFramePr>
+          <p:nvPr/>
+        </p:nvGraphicFramePr>
+        <p:xfrm>
+          <a:off x="900000" y="1380000"/>
+          <a:ext cx="11650000" cy="3840000"/>
+        </p:xfrm>
+        <a:graphic>
+          <a:graphicData uri="http://schemas.openxmlformats.org/drawingml/2006/table">
+            <a:tbl>
+              <a:tblPr firstRow="1" bandRow="0">
+                <a:tableStyleId>{5C22544A-7EE6-4342-B048-85BDC9FD1C3A}</a:tableStyleId>
+              </a:tblPr>
+              <a:tblGrid>
+                <a:gridCol w="699000"/>
+                <a:gridCol w="3728000"/>
+                <a:gridCol w="4427000"/>
+                <a:gridCol w="2796000"/>
+              </a:tblGrid>
+              <a:tr h="640000">
+                <a:tc>
+                  <a:txBody>
+                    <a:bodyPr wrap="square"/>
+                    <a:lstStyle/>
+                    <a:p>
+                      <a:pPr algn="l"/>
+                      <a:r>
+                        <a:rPr sz="1500" b="1">
+                          <a:solidFill>
+                            <a:srgbClr val="FFFFFF"/>
+                          </a:solidFill>
+                          <a:latin typeface="Arial"/>
+                        </a:rPr>
+                        <a:t>#</a:t>
+                      </a:r>
+                    </a:p>
+                  </a:txBody>
+                  <a:tcPr marL="70000" marR="70000" marT="30000" marB="30000" anchor="ctr">
+                    <a:solidFill>
+                      <a:srgbClr val="0F2F46"/>
+                    </a:solidFill>
+                  </a:tcPr>
+                </a:tc>
+                <a:tc>
+                  <a:txBody>
+                    <a:bodyPr wrap="square"/>
+                    <a:lstStyle/>
+                    <a:p>
+                      <a:pPr algn="l"/>
+                      <a:r>
+                        <a:rPr sz="1500" b="1">
+                          <a:solidFill>
+                            <a:srgbClr val="FFFFFF"/>
+                          </a:solidFill>
+                          <a:latin typeface="Arial"/>
+                        </a:rPr>
+                        <a:t>The gamification group…</a:t>
+                      </a:r>
+                    </a:p>
+                  </a:txBody>
+                  <a:tcPr marL="70000" marR="70000" marT="30000" marB="30000" anchor="ctr">
+                    <a:solidFill>
+                      <a:srgbClr val="0F2F46"/>
+                    </a:solidFill>
+                  </a:tcPr>
+                </a:tc>
+                <a:tc>
+                  <a:txBody>
+                    <a:bodyPr wrap="square"/>
+                    <a:lstStyle/>
+                    <a:p>
+                      <a:pPr algn="l"/>
+                      <a:r>
+                        <a:rPr sz="1500" b="1">
+                          <a:solidFill>
+                            <a:srgbClr val="FFFFFF"/>
+                          </a:solidFill>
+                          <a:latin typeface="Arial"/>
+                        </a:rPr>
+                        <a:t>Measure (app logs)</a:t>
+                      </a:r>
+                    </a:p>
+                  </a:txBody>
+                  <a:tcPr marL="70000" marR="70000" marT="30000" marB="30000" anchor="ctr">
+                    <a:solidFill>
+                      <a:srgbClr val="0F2F46"/>
+                    </a:solidFill>
+                  </a:tcPr>
+                </a:tc>
+                <a:tc>
+                  <a:txBody>
+                    <a:bodyPr wrap="square"/>
+                    <a:lstStyle/>
+                    <a:p>
+                      <a:pPr algn="l"/>
+                      <a:r>
+                        <a:rPr sz="1500" b="1">
+                          <a:solidFill>
+                            <a:srgbClr val="FFFFFF"/>
+                          </a:solidFill>
+                          <a:latin typeface="Arial"/>
+                        </a:rPr>
+                        <a:t>Test</a:t>
+                      </a:r>
+                    </a:p>
+                  </a:txBody>
+                  <a:tcPr marL="70000" marR="70000" marT="30000" marB="30000" anchor="ctr">
+                    <a:solidFill>
+                      <a:srgbClr val="0F2F46"/>
+                    </a:solidFill>
+                  </a:tcPr>
+                </a:tc>
+              </a:tr>
+              <a:tr h="640000">
+                <a:tc>
+                  <a:txBody>
+                    <a:bodyPr wrap="square"/>
+                    <a:lstStyle/>
+                    <a:p>
+                      <a:pPr algn="l"/>
+                      <a:r>
+                        <a:rPr sz="1500" b="0">
+                          <a:solidFill>
+                            <a:srgbClr val="262B30"/>
+                          </a:solidFill>
+                          <a:latin typeface="Arial"/>
+                        </a:rPr>
+                        <a:t>H1</a:t>
+                      </a:r>
+                    </a:p>
+                  </a:txBody>
+                  <a:tcPr marL="70000" marR="70000" marT="30000" marB="30000" anchor="ctr">
+                    <a:solidFill>
+                      <a:srgbClr val="FFFFFF"/>
+                    </a:solidFill>
+                  </a:tcPr>
+                </a:tc>
+                <a:tc>
+                  <a:txBody>
+                    <a:bodyPr wrap="square"/>
+                    <a:lstStyle/>
+                    <a:p>
+                      <a:pPr algn="l"/>
+                      <a:r>
+                        <a:rPr sz="1500" b="0">
+                          <a:solidFill>
+                            <a:srgbClr val="262B30"/>
+                          </a:solidFill>
+                          <a:latin typeface="Arial"/>
+                        </a:rPr>
+                        <a:t>visits more less popular checkpoints</a:t>
+                      </a:r>
+                    </a:p>
+                  </a:txBody>
+                  <a:tcPr marL="70000" marR="70000" marT="30000" marB="30000" anchor="ctr">
+                    <a:solidFill>
+                      <a:srgbClr val="FFFFFF"/>
+                    </a:solidFill>
+                  </a:tcPr>
+                </a:tc>
+                <a:tc>
+                  <a:txBody>
+                    <a:bodyPr wrap="square"/>
+                    <a:lstStyle/>
+                    <a:p>
+                      <a:pPr algn="l"/>
+                      <a:r>
+                        <a:rPr sz="1500" b="0">
+                          <a:solidFill>
+                            <a:srgbClr val="262B30"/>
+                          </a:solidFill>
+                          <a:latin typeface="Arial"/>
+                        </a:rPr>
+                        <a:t>Distinct less popular checkpoints visited</a:t>
+                      </a:r>
+                    </a:p>
+                  </a:txBody>
+                  <a:tcPr marL="70000" marR="70000" marT="30000" marB="30000" anchor="ctr">
+                    <a:solidFill>
+                      <a:srgbClr val="FFFFFF"/>
+                    </a:solidFill>
+                  </a:tcPr>
+                </a:tc>
+                <a:tc>
+                  <a:txBody>
+                    <a:bodyPr wrap="square"/>
+                    <a:lstStyle/>
+                    <a:p>
+                      <a:pPr algn="l"/>
+                      <a:r>
+                        <a:rPr sz="1500" b="0">
+                          <a:solidFill>
+                            <a:srgbClr val="262B30"/>
+                          </a:solidFill>
+                          <a:latin typeface="Arial"/>
+                        </a:rPr>
+                        <a:t>Mann–Whitney U</a:t>
+                      </a:r>
+                    </a:p>
+                  </a:txBody>
+                  <a:tcPr marL="70000" marR="70000" marT="30000" marB="30000" anchor="ctr">
+                    <a:solidFill>
+                      <a:srgbClr val="FFFFFF"/>
+                    </a:solidFill>
+                  </a:tcPr>
+                </a:tc>
+              </a:tr>
+              <a:tr h="640000">
+                <a:tc>
+                  <a:txBody>
+                    <a:bodyPr wrap="square"/>
+                    <a:lstStyle/>
+                    <a:p>
+                      <a:pPr algn="l"/>
+                      <a:r>
+                        <a:rPr sz="1500" b="0">
+                          <a:solidFill>
+                            <a:srgbClr val="262B30"/>
+                          </a:solidFill>
+                          <a:latin typeface="Arial"/>
+                        </a:rPr>
+                        <a:t>H2</a:t>
+                      </a:r>
+                    </a:p>
+                  </a:txBody>
+                  <a:tcPr marL="70000" marR="70000" marT="30000" marB="30000" anchor="ctr">
+                    <a:solidFill>
+                      <a:srgbClr val="E9F6F9"/>
+                    </a:solidFill>
+                  </a:tcPr>
+                </a:tc>
+                <a:tc>
+                  <a:txBody>
+                    <a:bodyPr wrap="square"/>
+                    <a:lstStyle/>
+                    <a:p>
+                      <a:pPr algn="l"/>
+                      <a:r>
+                        <a:rPr sz="1500" b="0">
+                          <a:solidFill>
+                            <a:srgbClr val="262B30"/>
+                          </a:solidFill>
+                          <a:latin typeface="Arial"/>
+                        </a:rPr>
+                        <a:t>has a larger share of visits at less popular checkpoints</a:t>
+                      </a:r>
+                    </a:p>
+                  </a:txBody>
+                  <a:tcPr marL="70000" marR="70000" marT="30000" marB="30000" anchor="ctr">
+                    <a:solidFill>
+                      <a:srgbClr val="E9F6F9"/>
+                    </a:solidFill>
+                  </a:tcPr>
+                </a:tc>
+                <a:tc>
+                  <a:txBody>
+                    <a:bodyPr wrap="square"/>
+                    <a:lstStyle/>
+                    <a:p>
+                      <a:pPr algn="l"/>
+                      <a:r>
+                        <a:rPr sz="1500" b="0">
+                          <a:solidFill>
+                            <a:srgbClr val="262B30"/>
+                          </a:solidFill>
+                          <a:latin typeface="Arial"/>
+                        </a:rPr>
+                        <a:t>Less popular visits ÷ all checkpoint visits</a:t>
+                      </a:r>
+                    </a:p>
+                  </a:txBody>
+                  <a:tcPr marL="70000" marR="70000" marT="30000" marB="30000" anchor="ctr">
+                    <a:solidFill>
+                      <a:srgbClr val="E9F6F9"/>
+                    </a:solidFill>
+                  </a:tcPr>
+                </a:tc>
+                <a:tc>
+                  <a:txBody>
+                    <a:bodyPr wrap="square"/>
+                    <a:lstStyle/>
+                    <a:p>
+                      <a:pPr algn="l"/>
+                      <a:r>
+                        <a:rPr sz="1500" b="0">
+                          <a:solidFill>
+                            <a:srgbClr val="262B30"/>
+                          </a:solidFill>
+                          <a:latin typeface="Arial"/>
+                        </a:rPr>
+                        <a:t>Mann–Whitney U</a:t>
+                      </a:r>
+                    </a:p>
+                  </a:txBody>
+                  <a:tcPr marL="70000" marR="70000" marT="30000" marB="30000" anchor="ctr">
+                    <a:solidFill>
+                      <a:srgbClr val="E9F6F9"/>
+                    </a:solidFill>
+                  </a:tcPr>
+                </a:tc>
+              </a:tr>
+              <a:tr h="640000">
+                <a:tc>
+                  <a:txBody>
+                    <a:bodyPr wrap="square"/>
+                    <a:lstStyle/>
+                    <a:p>
+                      <a:pPr algn="l"/>
+                      <a:r>
+                        <a:rPr sz="1500" b="0">
+                          <a:solidFill>
+                            <a:srgbClr val="262B30"/>
+                          </a:solidFill>
+                          <a:latin typeface="Arial"/>
+                        </a:rPr>
+                        <a:t>H3</a:t>
+                      </a:r>
+                    </a:p>
+                  </a:txBody>
+                  <a:tcPr marL="70000" marR="70000" marT="30000" marB="30000" anchor="ctr">
+                    <a:solidFill>
+                      <a:srgbClr val="FFFFFF"/>
+                    </a:solidFill>
+                  </a:tcPr>
+                </a:tc>
+                <a:tc>
+                  <a:txBody>
+                    <a:bodyPr wrap="square"/>
+                    <a:lstStyle/>
+                    <a:p>
+                      <a:pPr algn="l"/>
+                      <a:r>
+                        <a:rPr sz="1500" b="0">
+                          <a:solidFill>
+                            <a:srgbClr val="262B30"/>
+                          </a:solidFill>
+                          <a:latin typeface="Arial"/>
+                        </a:rPr>
+                        <a:t>travels farther from the crowded core</a:t>
+                      </a:r>
+                    </a:p>
+                  </a:txBody>
+                  <a:tcPr marL="70000" marR="70000" marT="30000" marB="30000" anchor="ctr">
+                    <a:solidFill>
+                      <a:srgbClr val="FFFFFF"/>
+                    </a:solidFill>
+                  </a:tcPr>
+                </a:tc>
+                <a:tc>
+                  <a:txBody>
+                    <a:bodyPr wrap="square"/>
+                    <a:lstStyle/>
+                    <a:p>
+                      <a:pPr algn="l"/>
+                      <a:r>
+                        <a:rPr sz="1500" b="0">
+                          <a:solidFill>
+                            <a:srgbClr val="262B30"/>
+                          </a:solidFill>
+                          <a:latin typeface="Arial"/>
+                        </a:rPr>
+                        <a:t>Max distance from Kaminarimon; time &gt; 300 m from popular spots</a:t>
+                      </a:r>
+                    </a:p>
+                  </a:txBody>
+                  <a:tcPr marL="70000" marR="70000" marT="30000" marB="30000" anchor="ctr">
+                    <a:solidFill>
+                      <a:srgbClr val="FFFFFF"/>
+                    </a:solidFill>
+                  </a:tcPr>
+                </a:tc>
+                <a:tc>
+                  <a:txBody>
+                    <a:bodyPr wrap="square"/>
+                    <a:lstStyle/>
+                    <a:p>
+                      <a:pPr algn="l"/>
+                      <a:r>
+                        <a:rPr sz="1500" b="0">
+                          <a:solidFill>
+                            <a:srgbClr val="262B30"/>
+                          </a:solidFill>
+                          <a:latin typeface="Arial"/>
+                        </a:rPr>
+                        <a:t>Mann–Whitney U</a:t>
+                      </a:r>
+                    </a:p>
+                  </a:txBody>
+                  <a:tcPr marL="70000" marR="70000" marT="30000" marB="30000" anchor="ctr">
+                    <a:solidFill>
+                      <a:srgbClr val="FFFFFF"/>
+                    </a:solidFill>
+                  </a:tcPr>
+                </a:tc>
+              </a:tr>
+              <a:tr h="640000">
+                <a:tc>
+                  <a:txBody>
+                    <a:bodyPr wrap="square"/>
+                    <a:lstStyle/>
+                    <a:p>
+                      <a:pPr algn="l"/>
+                      <a:r>
+                        <a:rPr sz="1500" b="0">
+                          <a:solidFill>
+                            <a:srgbClr val="262B30"/>
+                          </a:solidFill>
+                          <a:latin typeface="Arial"/>
+                        </a:rPr>
+                        <a:t>H4</a:t>
+                      </a:r>
+                    </a:p>
+                  </a:txBody>
+                  <a:tcPr marL="70000" marR="70000" marT="30000" marB="30000" anchor="ctr">
+                    <a:solidFill>
+                      <a:srgbClr val="E9F6F9"/>
+                    </a:solidFill>
+                  </a:tcPr>
+                </a:tc>
+                <a:tc>
+                  <a:txBody>
+                    <a:bodyPr wrap="square"/>
+                    <a:lstStyle/>
+                    <a:p>
+                      <a:pPr algn="l"/>
+                      <a:r>
+                        <a:rPr sz="1500" b="0">
+                          <a:solidFill>
+                            <a:srgbClr val="262B30"/>
+                          </a:solidFill>
+                          <a:latin typeface="Arial"/>
+                        </a:rPr>
+                        <a:t>shows an effect that differs by origin</a:t>
+                      </a:r>
+                    </a:p>
+                  </a:txBody>
+                  <a:tcPr marL="70000" marR="70000" marT="30000" marB="30000" anchor="ctr">
+                    <a:solidFill>
+                      <a:srgbClr val="E9F6F9"/>
+                    </a:solidFill>
+                  </a:tcPr>
+                </a:tc>
+                <a:tc>
+                  <a:txBody>
+                    <a:bodyPr wrap="square"/>
+                    <a:lstStyle/>
+                    <a:p>
+                      <a:pPr algn="l"/>
+                      <a:r>
+                        <a:rPr sz="1500" b="0">
+                          <a:solidFill>
+                            <a:srgbClr val="262B30"/>
+                          </a:solidFill>
+                          <a:latin typeface="Arial"/>
+                        </a:rPr>
+                        <a:t>H1 measure by group × Japanese / foreign</a:t>
+                      </a:r>
+                    </a:p>
+                  </a:txBody>
+                  <a:tcPr marL="70000" marR="70000" marT="30000" marB="30000" anchor="ctr">
+                    <a:solidFill>
+                      <a:srgbClr val="E9F6F9"/>
+                    </a:solidFill>
+                  </a:tcPr>
+                </a:tc>
+                <a:tc>
+                  <a:txBody>
+                    <a:bodyPr wrap="square"/>
+                    <a:lstStyle/>
+                    <a:p>
+                      <a:pPr algn="l"/>
+                      <a:r>
+                        <a:rPr sz="1500" b="0">
+                          <a:solidFill>
+                            <a:srgbClr val="262B30"/>
+                          </a:solidFill>
+                          <a:latin typeface="Arial"/>
+                        </a:rPr>
+                        <a:t>Poisson / neg. binomial regression</a:t>
+                      </a:r>
+                    </a:p>
+                  </a:txBody>
+                  <a:tcPr marL="70000" marR="70000" marT="30000" marB="30000" anchor="ctr">
+                    <a:solidFill>
+                      <a:srgbClr val="E9F6F9"/>
+                    </a:solidFill>
+                  </a:tcPr>
+                </a:tc>
+              </a:tr>
+              <a:tr h="640000">
+                <a:tc>
+                  <a:txBody>
+                    <a:bodyPr wrap="square"/>
+                    <a:lstStyle/>
+                    <a:p>
+                      <a:pPr algn="l"/>
+                      <a:r>
+                        <a:rPr sz="1500" b="0">
+                          <a:solidFill>
+                            <a:srgbClr val="262B30"/>
+                          </a:solidFill>
+                          <a:latin typeface="Arial"/>
+                        </a:rPr>
+                        <a:t>H5</a:t>
+                      </a:r>
+                    </a:p>
+                  </a:txBody>
+                  <a:tcPr marL="70000" marR="70000" marT="30000" marB="30000" anchor="ctr">
+                    <a:solidFill>
+                      <a:srgbClr val="FFFFFF"/>
+                    </a:solidFill>
+                  </a:tcPr>
+                </a:tc>
+                <a:tc>
+                  <a:txBody>
+                    <a:bodyPr wrap="square"/>
+                    <a:lstStyle/>
+                    <a:p>
+                      <a:pPr algn="l"/>
+                      <a:r>
+                        <a:rPr sz="1500" b="0">
+                          <a:solidFill>
+                            <a:srgbClr val="262B30"/>
+                          </a:solidFill>
+                          <a:latin typeface="Arial"/>
+                        </a:rPr>
+                        <a:t>is no less satisfied with the trip</a:t>
+                      </a:r>
+                    </a:p>
+                  </a:txBody>
+                  <a:tcPr marL="70000" marR="70000" marT="30000" marB="30000" anchor="ctr">
+                    <a:solidFill>
+                      <a:srgbClr val="FFFFFF"/>
+                    </a:solidFill>
+                  </a:tcPr>
+                </a:tc>
+                <a:tc>
+                  <a:txBody>
+                    <a:bodyPr wrap="square"/>
+                    <a:lstStyle/>
+                    <a:p>
+                      <a:pPr algn="l"/>
+                      <a:r>
+                        <a:rPr sz="1500" b="0">
+                          <a:solidFill>
+                            <a:srgbClr val="262B30"/>
+                          </a:solidFill>
+                          <a:latin typeface="Arial"/>
+                        </a:rPr>
+                        <a:t>Post-survey satisfaction</a:t>
+                      </a:r>
+                    </a:p>
+                  </a:txBody>
+                  <a:tcPr marL="70000" marR="70000" marT="30000" marB="30000" anchor="ctr">
+                    <a:solidFill>
+                      <a:srgbClr val="FFFFFF"/>
+                    </a:solidFill>
+                  </a:tcPr>
+                </a:tc>
+                <a:tc>
+                  <a:txBody>
+                    <a:bodyPr wrap="square"/>
+                    <a:lstStyle/>
+                    <a:p>
+                      <a:pPr algn="l"/>
+                      <a:r>
+                        <a:rPr sz="1500" b="0">
+                          <a:solidFill>
+                            <a:srgbClr val="262B30"/>
+                          </a:solidFill>
+                          <a:latin typeface="Arial"/>
+                        </a:rPr>
+                        <a:t>Mann–Whitney U</a:t>
+                      </a:r>
+                    </a:p>
+                  </a:txBody>
+                  <a:tcPr marL="70000" marR="70000" marT="30000" marB="30000" anchor="ctr">
+                    <a:solidFill>
+                      <a:srgbClr val="FFFFFF"/>
+                    </a:solidFill>
+                  </a:tcPr>
+                </a:tc>
+              </a:tr>
+            </a:tbl>
+          </a:graphicData>
+        </a:graphic>
+      </p:graphicFrame>
+      <p:sp>
+        <p:nvSpPr>
+          <p:cNvPr id="54" name="H1 H2 note"/>
+          <p:cNvSpPr/>
+          <p:nvPr/>
+        </p:nvSpPr>
+        <p:spPr>
+          <a:xfrm>
+            <a:off x="900000" y="5630000"/>
+            <a:ext cx="11650000" cy="1150000"/>
+          </a:xfrm>
+          <a:prstGeom prst="roundRect">
+            <a:avLst>
+              <a:gd name="adj" fmla="val 6000"/>
+            </a:avLst>
+          </a:prstGeom>
+          <a:solidFill>
+            <a:srgbClr val="E9F6F9"/>
+          </a:solidFill>
+          <a:ln>
+            <a:noFill/>
+          </a:ln>
+          <a:effectLst/>
+        </p:spPr>
+        <p:style>
+          <a:lnRef idx="1">
+            <a:schemeClr val="accent1"/>
+          </a:lnRef>
+          <a:fillRef idx="3">
+            <a:schemeClr val="accent1"/>
+          </a:fillRef>
+          <a:effectRef idx="2">
+            <a:schemeClr val="accent1"/>
+          </a:effectRef>
+          <a:fontRef idx="minor">
+            <a:schemeClr val="lt1"/>
+          </a:fontRef>
+        </p:style>
+        <p:txBody>
+          <a:bodyPr rtlCol="0" anchor="ctr"/>
+          <a:lstStyle/>
+          <a:p/>
+        </p:txBody>
+      </p:sp>
+      <p:sp>
+        <p:nvSpPr>
+          <p:cNvPr id="55" name="TextBox 54"/>
+          <p:cNvSpPr txBox="1"/>
+          <p:nvPr/>
+        </p:nvSpPr>
+        <p:spPr>
+          <a:xfrm>
+            <a:off x="1180000" y="5630000"/>
+            <a:ext cx="11090000" cy="1150000"/>
+          </a:xfrm>
+          <a:prstGeom prst="rect">
+            <a:avLst/>
+          </a:prstGeom>
+          <a:noFill/>
+        </p:spPr>
+        <p:txBody>
+          <a:bodyPr wrap="square" anchor="ctr" lIns="0" rIns="0" tIns="0" bIns="0">
+            <a:spAutoFit/>
+          </a:bodyPr>
+          <a:lstStyle/>
+          <a:p>
+            <a:pPr algn="l">
+              <a:spcAft>
+                <a:spcPts val="0"/>
+              </a:spcAft>
+            </a:pPr>
+            <a:r>
+              <a:rPr sz="1600" b="1">
+                <a:solidFill>
+                  <a:srgbClr val="0F2F46"/>
+                </a:solidFill>
+                <a:latin typeface="Arial"/>
+              </a:rPr>
+              <a:t>Why H1 and H2 together: </a:t>
+            </a:r>
+            <a:r>
+              <a:rPr sz="1600" b="0">
+                <a:solidFill>
+                  <a:srgbClr val="0F2F46"/>
+                </a:solidFill>
+                <a:latin typeface="Arial"/>
+              </a:rPr>
+              <a:t>gamification may raise visits everywhere. H1 alone could rise with no shift away from popular spots; H2 shows whether the balance actually moves.</a:t>
+            </a:r>
+          </a:p>
+        </p:txBody>
+      </p:sp>
+    </p:spTree>
+  </p:cSld>
+  <p:clrMapOvr>
+    <a:masterClrMapping/>
+  </p:clrMapOvr>
+</p:sld>
+</file>
+
+<file path=ppt/slides/slide11.xml><?xml version="1.0" encoding="utf-8"?>
+<p:sld xmlns:a="http://schemas.openxmlformats.org/drawingml/2006/main" xmlns:r="http://schemas.openxmlformats.org/officeDocument/2006/relationships" xmlns:mc="http://schemas.openxmlformats.org/markup-compatibility/2006" xmlns:mv="urn:schemas-microsoft-com:mac:vml" xmlns:p="http://schemas.openxmlformats.org/presentationml/2006/main" xmlns:c="http://schemas.openxmlformats.org/drawingml/2006/chart" xmlns:dgm="http://schemas.openxmlformats.org/drawingml/2006/diagram" xmlns:o="urn:schemas-microsoft-com:office:office" xmlns:v="urn:schemas-microsoft-com:vml" xmlns:pvml="urn:schemas-microsoft-com:office:powerpoint" xmlns:com="http://schemas.openxmlformats.org/drawingml/2006/compatibility" xmlns:p14="http://schemas.microsoft.com/office/powerpoint/2010/main" xmlns:p15="http://schemas.microsoft.com/office/powerpoint/2012/main" xmlns:ahyp="http://schemas.microsoft.com/office/drawing/2018/hyperlinkcolor">
+  <p:cSld>
+    <p:spTree>
+      <p:nvGrpSpPr>
+        <p:cNvPr id="50" name="Shape 50"/>
+        <p:cNvGrpSpPr/>
+        <p:nvPr/>
+      </p:nvGrpSpPr>
+      <p:grpSpPr>
+        <a:xfrm>
+          <a:off x="0" y="0"/>
+          <a:ext cx="0" cy="0"/>
+          <a:chOff x="0" y="0"/>
+          <a:chExt cx="0" cy="0"/>
+        </a:xfrm>
+      </p:grpSpPr>
+      <p:sp>
+        <p:nvSpPr>
+          <p:cNvPr id="51" name="Google Shape;51;p8"/>
+          <p:cNvSpPr txBox="1"/>
+          <p:nvPr>
+            <p:ph idx="12" type="sldNum"/>
+          </p:nvPr>
+        </p:nvSpPr>
+        <p:spPr>
+          <a:xfrm>
+            <a:off x="9074817" y="7033452"/>
+            <a:ext cx="2459482" cy="276999"/>
+          </a:xfrm>
+          <a:prstGeom prst="rect">
+            <a:avLst/>
+          </a:prstGeom>
+          <a:noFill/>
+          <a:ln>
+            <a:noFill/>
+          </a:ln>
+        </p:spPr>
+        <p:txBody>
+          <a:bodyPr anchorCtr="0" anchor="t" bIns="0" lIns="0" spcFirstLastPara="1" rIns="0" wrap="square" tIns="0">
+            <a:noAutofit/>
+          </a:bodyPr>
+          <a:lstStyle/>
+          <a:p>
+            <a:pPr indent="0" lvl="0" marL="0" rtl="0" algn="r">
+              <a:lnSpc>
+                <a:spcPct val="100000"/>
+              </a:lnSpc>
+              <a:spcBef>
+                <a:spcPts val="0"/>
+              </a:spcBef>
+              <a:spcAft>
+                <a:spcPts val="0"/>
+              </a:spcAft>
+              <a:buSzPts val="1800"/>
+              <a:buNone/>
+            </a:pPr>
+            <a:fld id="{00000000-1234-1234-1234-123412341234}" type="slidenum">
+              <a:rPr lang="en-US"/>
+              <a:t>‹#›</a:t>
+            </a:fld>
+            <a:endParaRPr/>
+          </a:p>
+        </p:txBody>
+      </p:sp>
+      <p:sp>
+        <p:nvSpPr>
+          <p:cNvPr id="52" name="Google Shape;52;p8"/>
+          <p:cNvSpPr txBox="1"/>
+          <p:nvPr/>
+        </p:nvSpPr>
+        <p:spPr>
+          <a:xfrm>
+            <a:off x="898635" y="409903"/>
+            <a:ext cx="9800000" cy="584775"/>
+          </a:xfrm>
+          <a:prstGeom prst="rect">
+            <a:avLst/>
+          </a:prstGeom>
+          <a:noFill/>
+          <a:ln>
+            <a:noFill/>
+          </a:ln>
+        </p:spPr>
+        <p:txBody>
+          <a:bodyPr anchorCtr="0" anchor="t" bIns="45700" lIns="91425" spcFirstLastPara="1" rIns="91425" wrap="square" tIns="45700">
+            <a:spAutoFit/>
+          </a:bodyPr>
+          <a:lstStyle/>
+          <a:p>
+            <a:pPr indent="0" lvl="0" marL="0" marR="0" rtl="0" algn="l">
+              <a:lnSpc>
+                <a:spcPct val="100000"/>
+              </a:lnSpc>
+              <a:spcBef>
+                <a:spcPts val="0"/>
+              </a:spcBef>
+              <a:spcAft>
+                <a:spcPts val="0"/>
+              </a:spcAft>
+              <a:buNone/>
+            </a:pPr>
+            <a:r>
+              <a:rPr b="1" i="0" lang="en-US" sz="3200" u="none" cap="none" strike="noStrike">
+                <a:solidFill>
+                  <a:srgbClr val="000000"/>
+                </a:solidFill>
+                <a:latin typeface="Arial"/>
+                <a:ea typeface="Arial"/>
+                <a:cs typeface="Arial"/>
+                <a:sym typeface="Arial"/>
+              </a:rPr>
               <a:t>Surveys and app changes</a:t>
             </a:r>
             <a:endParaRPr/>
@@ -8928,7 +9739,7 @@
                 </a:solidFill>
                 <a:latin typeface="Arial"/>
               </a:rPr>
-              <a:t>Spot-dependent points: </a:t>
+              <a:t>Stamp rally and missions </a:t>
             </a:r>
             <a:r>
               <a:rPr sz="1700" b="0">
@@ -8937,7 +9748,7 @@
                 </a:solidFill>
                 <a:latin typeface="Arial"/>
               </a:rPr>
-              <a:t>every check-in gives 10 points now</a:t>
+              <a:t>at all 16 checkpoints; equal points everywhere (current 10 per check-in is fine)</a:t>
             </a:r>
           </a:p>
           <a:p>
@@ -9028,7 +9839,7 @@
 </p:sld>
 </file>
 
-<file path=ppt/slides/slide11.xml><?xml version="1.0" encoding="utf-8"?>
+<file path=ppt/slides/slide12.xml><?xml version="1.0" encoding="utf-8"?>
 <p:sld xmlns:a="http://schemas.openxmlformats.org/drawingml/2006/main" xmlns:r="http://schemas.openxmlformats.org/officeDocument/2006/relationships" xmlns:mc="http://schemas.openxmlformats.org/markup-compatibility/2006" xmlns:mv="urn:schemas-microsoft-com:mac:vml" xmlns:p="http://schemas.openxmlformats.org/presentationml/2006/main" xmlns:c="http://schemas.openxmlformats.org/drawingml/2006/chart" xmlns:dgm="http://schemas.openxmlformats.org/drawingml/2006/diagram" xmlns:o="urn:schemas-microsoft-com:office:office" xmlns:v="urn:schemas-microsoft-com:vml" xmlns:pvml="urn:schemas-microsoft-com:office:powerpoint" xmlns:com="http://schemas.openxmlformats.org/drawingml/2006/compatibility" xmlns:p14="http://schemas.microsoft.com/office/powerpoint/2010/main" xmlns:p15="http://schemas.microsoft.com/office/powerpoint/2012/main" xmlns:ahyp="http://schemas.microsoft.com/office/drawing/2018/hyperlinkcolor">
   <p:cSld>
     <p:spTree>
@@ -9474,7 +10285,7 @@
                 </a:solidFill>
                 <a:latin typeface="Arial"/>
               </a:rPr>
-              <a:t>2. Two groups or three? What sample size can we realistically recruit?</a:t>
+              <a:t>2. What sample size can we realistically recruit (26 or 64 per group)?</a:t>
             </a:r>
           </a:p>
           <a:p>
@@ -9645,7 +10456,7 @@
         </p:nvSpPr>
         <p:spPr>
           <a:xfrm>
-            <a:off x="900000" y="1500000"/>
+            <a:off x="900000" y="1440000"/>
             <a:ext cx="520000" cy="520000"/>
           </a:xfrm>
           <a:prstGeom prst="ellipse">
@@ -9687,7 +10498,7 @@
         </p:nvSpPr>
         <p:spPr>
           <a:xfrm>
-            <a:off x="900000" y="1500000"/>
+            <a:off x="900000" y="1440000"/>
             <a:ext cx="520000" cy="520000"/>
           </a:xfrm>
           <a:prstGeom prst="rect">
@@ -9726,7 +10537,7 @@
         </p:nvSpPr>
         <p:spPr>
           <a:xfrm>
-            <a:off x="1650000" y="1500000"/>
+            <a:off x="1650000" y="1440000"/>
             <a:ext cx="9000000" cy="520000"/>
           </a:xfrm>
           <a:prstGeom prst="rect">
@@ -9765,7 +10576,7 @@
         </p:nvSpPr>
         <p:spPr>
           <a:xfrm>
-            <a:off x="900000" y="2140000"/>
+            <a:off x="900000" y="2040000"/>
             <a:ext cx="520000" cy="520000"/>
           </a:xfrm>
           <a:prstGeom prst="ellipse">
@@ -9807,7 +10618,7 @@
         </p:nvSpPr>
         <p:spPr>
           <a:xfrm>
-            <a:off x="900000" y="2140000"/>
+            <a:off x="900000" y="2040000"/>
             <a:ext cx="520000" cy="520000"/>
           </a:xfrm>
           <a:prstGeom prst="rect">
@@ -9846,7 +10657,7 @@
         </p:nvSpPr>
         <p:spPr>
           <a:xfrm>
-            <a:off x="1650000" y="2140000"/>
+            <a:off x="1650000" y="2040000"/>
             <a:ext cx="9000000" cy="520000"/>
           </a:xfrm>
           <a:prstGeom prst="rect">
@@ -9885,7 +10696,7 @@
         </p:nvSpPr>
         <p:spPr>
           <a:xfrm>
-            <a:off x="900000" y="2780000"/>
+            <a:off x="900000" y="2640000"/>
             <a:ext cx="520000" cy="520000"/>
           </a:xfrm>
           <a:prstGeom prst="ellipse">
@@ -9927,7 +10738,7 @@
         </p:nvSpPr>
         <p:spPr>
           <a:xfrm>
-            <a:off x="900000" y="2780000"/>
+            <a:off x="900000" y="2640000"/>
             <a:ext cx="520000" cy="520000"/>
           </a:xfrm>
           <a:prstGeom prst="rect">
@@ -9966,7 +10777,7 @@
         </p:nvSpPr>
         <p:spPr>
           <a:xfrm>
-            <a:off x="1650000" y="2780000"/>
+            <a:off x="1650000" y="2640000"/>
             <a:ext cx="9000000" cy="520000"/>
           </a:xfrm>
           <a:prstGeom prst="rect">
@@ -10005,7 +10816,7 @@
         </p:nvSpPr>
         <p:spPr>
           <a:xfrm>
-            <a:off x="900000" y="3420000"/>
+            <a:off x="900000" y="3240000"/>
             <a:ext cx="520000" cy="520000"/>
           </a:xfrm>
           <a:prstGeom prst="ellipse">
@@ -10047,7 +10858,7 @@
         </p:nvSpPr>
         <p:spPr>
           <a:xfrm>
-            <a:off x="900000" y="3420000"/>
+            <a:off x="900000" y="3240000"/>
             <a:ext cx="520000" cy="520000"/>
           </a:xfrm>
           <a:prstGeom prst="rect">
@@ -10086,7 +10897,7 @@
         </p:nvSpPr>
         <p:spPr>
           <a:xfrm>
-            <a:off x="1650000" y="3420000"/>
+            <a:off x="1650000" y="3240000"/>
             <a:ext cx="9000000" cy="520000"/>
           </a:xfrm>
           <a:prstGeom prst="rect">
@@ -10125,7 +10936,7 @@
         </p:nvSpPr>
         <p:spPr>
           <a:xfrm>
-            <a:off x="900000" y="4060000"/>
+            <a:off x="900000" y="3840000"/>
             <a:ext cx="520000" cy="520000"/>
           </a:xfrm>
           <a:prstGeom prst="ellipse">
@@ -10167,7 +10978,7 @@
         </p:nvSpPr>
         <p:spPr>
           <a:xfrm>
-            <a:off x="900000" y="4060000"/>
+            <a:off x="900000" y="3840000"/>
             <a:ext cx="520000" cy="520000"/>
           </a:xfrm>
           <a:prstGeom prst="rect">
@@ -10206,7 +11017,7 @@
         </p:nvSpPr>
         <p:spPr>
           <a:xfrm>
-            <a:off x="1650000" y="4060000"/>
+            <a:off x="1650000" y="3840000"/>
             <a:ext cx="9000000" cy="520000"/>
           </a:xfrm>
           <a:prstGeom prst="rect">
@@ -10245,7 +11056,7 @@
         </p:nvSpPr>
         <p:spPr>
           <a:xfrm>
-            <a:off x="900000" y="4700000"/>
+            <a:off x="900000" y="4440000"/>
             <a:ext cx="520000" cy="520000"/>
           </a:xfrm>
           <a:prstGeom prst="ellipse">
@@ -10287,7 +11098,7 @@
         </p:nvSpPr>
         <p:spPr>
           <a:xfrm>
-            <a:off x="900000" y="4700000"/>
+            <a:off x="900000" y="4440000"/>
             <a:ext cx="520000" cy="520000"/>
           </a:xfrm>
           <a:prstGeom prst="rect">
@@ -10326,7 +11137,7 @@
         </p:nvSpPr>
         <p:spPr>
           <a:xfrm>
-            <a:off x="1650000" y="4700000"/>
+            <a:off x="1650000" y="4440000"/>
             <a:ext cx="9000000" cy="520000"/>
           </a:xfrm>
           <a:prstGeom prst="rect">
@@ -10365,7 +11176,7 @@
         </p:nvSpPr>
         <p:spPr>
           <a:xfrm>
-            <a:off x="900000" y="5340000"/>
+            <a:off x="900000" y="5040000"/>
             <a:ext cx="520000" cy="520000"/>
           </a:xfrm>
           <a:prstGeom prst="ellipse">
@@ -10407,7 +11218,7 @@
         </p:nvSpPr>
         <p:spPr>
           <a:xfrm>
-            <a:off x="900000" y="5340000"/>
+            <a:off x="900000" y="5040000"/>
             <a:ext cx="520000" cy="520000"/>
           </a:xfrm>
           <a:prstGeom prst="rect">
@@ -10446,7 +11257,7 @@
         </p:nvSpPr>
         <p:spPr>
           <a:xfrm>
-            <a:off x="1650000" y="5340000"/>
+            <a:off x="1650000" y="5040000"/>
             <a:ext cx="9000000" cy="520000"/>
           </a:xfrm>
           <a:prstGeom prst="rect">
@@ -10472,7 +11283,7 @@
                 </a:solidFill>
                 <a:latin typeface="Arial"/>
               </a:rPr>
-              <a:t>Surveys and app changes</a:t>
+              <a:t>Hypotheses and measures</a:t>
             </a:r>
           </a:p>
         </p:txBody>
@@ -10485,7 +11296,7 @@
         </p:nvSpPr>
         <p:spPr>
           <a:xfrm>
-            <a:off x="900000" y="5980000"/>
+            <a:off x="900000" y="5640000"/>
             <a:ext cx="520000" cy="520000"/>
           </a:xfrm>
           <a:prstGeom prst="ellipse">
@@ -10527,7 +11338,7 @@
         </p:nvSpPr>
         <p:spPr>
           <a:xfrm>
-            <a:off x="900000" y="5980000"/>
+            <a:off x="900000" y="5640000"/>
             <a:ext cx="520000" cy="520000"/>
           </a:xfrm>
           <a:prstGeom prst="rect">
@@ -10566,7 +11377,127 @@
         </p:nvSpPr>
         <p:spPr>
           <a:xfrm>
-            <a:off x="1650000" y="5980000"/>
+            <a:off x="1650000" y="5640000"/>
+            <a:ext cx="9000000" cy="520000"/>
+          </a:xfrm>
+          <a:prstGeom prst="rect">
+            <a:avLst/>
+          </a:prstGeom>
+          <a:noFill/>
+        </p:spPr>
+        <p:txBody>
+          <a:bodyPr wrap="square" anchor="ctr" lIns="0" rIns="0" tIns="0" bIns="0">
+            <a:spAutoFit/>
+          </a:bodyPr>
+          <a:lstStyle/>
+          <a:p>
+            <a:pPr algn="l">
+              <a:spcAft>
+                <a:spcPts val="0"/>
+              </a:spcAft>
+            </a:pPr>
+            <a:r>
+              <a:rPr sz="2000" b="0">
+                <a:solidFill>
+                  <a:srgbClr val="262B30"/>
+                </a:solidFill>
+                <a:latin typeface="Arial"/>
+              </a:rPr>
+              <a:t>Surveys and app changes</a:t>
+            </a:r>
+          </a:p>
+        </p:txBody>
+      </p:sp>
+      <p:sp>
+        <p:nvSpPr>
+          <p:cNvPr id="77" name="TOC number 9"/>
+          <p:cNvSpPr/>
+          <p:nvPr/>
+        </p:nvSpPr>
+        <p:spPr>
+          <a:xfrm>
+            <a:off x="900000" y="6240000"/>
+            <a:ext cx="520000" cy="520000"/>
+          </a:xfrm>
+          <a:prstGeom prst="ellipse">
+            <a:avLst/>
+          </a:prstGeom>
+          <a:solidFill>
+            <a:srgbClr val="7BCFDF"/>
+          </a:solidFill>
+          <a:ln>
+            <a:noFill/>
+          </a:ln>
+          <a:effectLst/>
+        </p:spPr>
+        <p:style>
+          <a:lnRef idx="1">
+            <a:schemeClr val="accent1"/>
+          </a:lnRef>
+          <a:fillRef idx="3">
+            <a:schemeClr val="accent1"/>
+          </a:fillRef>
+          <a:effectRef idx="2">
+            <a:schemeClr val="accent1"/>
+          </a:effectRef>
+          <a:fontRef idx="minor">
+            <a:schemeClr val="lt1"/>
+          </a:fontRef>
+        </p:style>
+        <p:txBody>
+          <a:bodyPr rtlCol="0" anchor="ctr"/>
+          <a:lstStyle/>
+          <a:p/>
+        </p:txBody>
+      </p:sp>
+      <p:sp>
+        <p:nvSpPr>
+          <p:cNvPr id="78" name="TextBox 77"/>
+          <p:cNvSpPr txBox="1"/>
+          <p:nvPr/>
+        </p:nvSpPr>
+        <p:spPr>
+          <a:xfrm>
+            <a:off x="900000" y="6240000"/>
+            <a:ext cx="520000" cy="520000"/>
+          </a:xfrm>
+          <a:prstGeom prst="rect">
+            <a:avLst/>
+          </a:prstGeom>
+          <a:noFill/>
+        </p:spPr>
+        <p:txBody>
+          <a:bodyPr wrap="square" anchor="ctr" lIns="0" rIns="0" tIns="0" bIns="0">
+            <a:spAutoFit/>
+          </a:bodyPr>
+          <a:lstStyle/>
+          <a:p>
+            <a:pPr algn="ctr">
+              <a:spcAft>
+                <a:spcPts val="0"/>
+              </a:spcAft>
+            </a:pPr>
+            <a:r>
+              <a:rPr sz="1800" b="1">
+                <a:solidFill>
+                  <a:srgbClr val="0F2F46"/>
+                </a:solidFill>
+                <a:latin typeface="Arial"/>
+              </a:rPr>
+              <a:t>9</a:t>
+            </a:r>
+          </a:p>
+        </p:txBody>
+      </p:sp>
+      <p:sp>
+        <p:nvSpPr>
+          <p:cNvPr id="79" name="TextBox 78"/>
+          <p:cNvSpPr txBox="1"/>
+          <p:nvPr/>
+        </p:nvSpPr>
+        <p:spPr>
+          <a:xfrm>
+            <a:off x="1650000" y="6240000"/>
             <a:ext cx="9000000" cy="520000"/>
           </a:xfrm>
           <a:prstGeom prst="rect">
@@ -10817,7 +11748,7 @@
                 </a:solidFill>
                 <a:latin typeface="Arial"/>
               </a:rPr>
-              <a:t>Can gamification and incentives in a tourism app move visitors from crowded famous spots to less popular spots nearby?</a:t>
+              <a:t>Can gamification features in a tourism app lead visitors from crowded famous spots to less popular spots nearby?</a:t>
             </a:r>
           </a:p>
         </p:txBody>
@@ -11192,7 +12123,7 @@
                           </a:solidFill>
                           <a:latin typeface="Arial"/>
                         </a:rPr>
-                        <a:t>Yes (no gamification)</a:t>
+                        <a:t>Yes: with vs without gamification</a:t>
                       </a:r>
                     </a:p>
                   </a:txBody>
@@ -16708,7 +17639,7 @@
                 <a:cs typeface="Arial"/>
                 <a:sym typeface="Arial"/>
               </a:rPr>
-              <a:t>Experiment design: groups and sample size</a:t>
+              <a:t>Experiment design: with vs without gamification</a:t>
             </a:r>
             <a:endParaRPr/>
           </a:p>
@@ -16724,7 +17655,7 @@
         </p:nvGraphicFramePr>
         <p:xfrm>
           <a:off x="900000" y="1380000"/>
-          <a:ext cx="7300000" cy="3200000"/>
+          <a:ext cx="7300000" cy="2100000"/>
         </p:xfrm>
         <a:graphic>
           <a:graphicData uri="http://schemas.openxmlformats.org/drawingml/2006/table">
@@ -16733,11 +17664,10 @@
                 <a:tableStyleId>{5C22544A-7EE6-4342-B048-85BDC9FD1C3A}</a:tableStyleId>
               </a:tblPr>
               <a:tblGrid>
-                <a:gridCol w="1898000"/>
-                <a:gridCol w="3358000"/>
-                <a:gridCol w="2044000"/>
+                <a:gridCol w="2482000"/>
+                <a:gridCol w="4818000"/>
               </a:tblGrid>
-              <a:tr h="800000">
+              <a:tr h="700000">
                 <a:tc>
                   <a:txBody>
                     <a:bodyPr wrap="square"/>
@@ -16745,7 +17675,7 @@
                     <a:p>
                       <a:pPr algn="l"/>
                       <a:r>
-                        <a:rPr sz="1400" b="1">
+                        <a:rPr sz="1500" b="1">
                           <a:solidFill>
                             <a:srgbClr val="FFFFFF"/>
                           </a:solidFill>
@@ -16768,7 +17698,7 @@
                     <a:p>
                       <a:pPr algn="l"/>
                       <a:r>
-                        <a:rPr sz="1400" b="1">
+                        <a:rPr sz="1500" b="1">
                           <a:solidFill>
                             <a:srgbClr val="FFFFFF"/>
                           </a:solidFill>
@@ -16784,6 +17714,8 @@
                     </a:solidFill>
                   </a:tcPr>
                 </a:tc>
+              </a:tr>
+              <a:tr h="700000">
                 <a:tc>
                   <a:txBody>
                     <a:bodyPr wrap="square"/>
@@ -16791,38 +17723,13 @@
                     <a:p>
                       <a:pPr algn="l"/>
                       <a:r>
-                        <a:rPr sz="1400" b="1">
-                          <a:solidFill>
-                            <a:srgbClr val="FFFFFF"/>
-                          </a:solidFill>
-                          <a:latin typeface="Arial"/>
-                        </a:rPr>
-                        <a:t>What it tests</a:t>
-                      </a:r>
-                    </a:p>
-                  </a:txBody>
-                  <a:tcPr marL="70000" marR="70000" marT="30000" marB="30000" anchor="ctr">
-                    <a:solidFill>
-                      <a:srgbClr val="0F2F46"/>
-                    </a:solidFill>
-                  </a:tcPr>
-                </a:tc>
-              </a:tr>
-              <a:tr h="800000">
-                <a:tc>
-                  <a:txBody>
-                    <a:bodyPr wrap="square"/>
-                    <a:lstStyle/>
-                    <a:p>
-                      <a:pPr algn="l"/>
-                      <a:r>
-                        <a:rPr sz="1400" b="0">
+                        <a:rPr sz="1500" b="0">
                           <a:solidFill>
                             <a:srgbClr val="262B30"/>
                           </a:solidFill>
                           <a:latin typeface="Arial"/>
                         </a:rPr>
-                        <a:t>Control</a:t>
+                        <a:t>Without gamification (control)</a:t>
                       </a:r>
                     </a:p>
                   </a:txBody>
@@ -16839,36 +17746,13 @@
                     <a:p>
                       <a:pPr algn="l"/>
                       <a:r>
-                        <a:rPr sz="1400" b="0">
+                        <a:rPr sz="1500" b="0">
                           <a:solidFill>
                             <a:srgbClr val="262B30"/>
                           </a:solidFill>
                           <a:latin typeface="Arial"/>
                         </a:rPr>
-                        <a:t>Map and spot information only</a:t>
-                      </a:r>
-                    </a:p>
-                  </a:txBody>
-                  <a:tcPr marL="70000" marR="70000" marT="30000" marB="30000" anchor="ctr">
-                    <a:solidFill>
-                      <a:srgbClr val="FFFFFF"/>
-                    </a:solidFill>
-                  </a:tcPr>
-                </a:tc>
-                <a:tc>
-                  <a:txBody>
-                    <a:bodyPr wrap="square"/>
-                    <a:lstStyle/>
-                    <a:p>
-                      <a:pPr algn="l"/>
-                      <a:r>
-                        <a:rPr sz="1400" b="0">
-                          <a:solidFill>
-                            <a:srgbClr val="262B30"/>
-                          </a:solidFill>
-                          <a:latin typeface="Arial"/>
-                        </a:rPr>
-                        <a:t>Baseline behaviour</a:t>
+                        <a:t>Map with all 16 checkpoints and spot information</a:t>
                       </a:r>
                     </a:p>
                   </a:txBody>
@@ -16879,7 +17763,7 @@
                   </a:tcPr>
                 </a:tc>
               </a:tr>
-              <a:tr h="800000">
+              <a:tr h="700000">
                 <a:tc>
                   <a:txBody>
                     <a:bodyPr wrap="square"/>
@@ -16887,13 +17771,13 @@
                     <a:p>
                       <a:pPr algn="l"/>
                       <a:r>
-                        <a:rPr sz="1400" b="0">
+                        <a:rPr sz="1500" b="0">
                           <a:solidFill>
                             <a:srgbClr val="262B30"/>
                           </a:solidFill>
                           <a:latin typeface="Arial"/>
                         </a:rPr>
-                        <a:t>Gamification</a:t>
+                        <a:t>With gamification</a:t>
                       </a:r>
                     </a:p>
                   </a:txBody>
@@ -16910,113 +17794,19 @@
                     <a:p>
                       <a:pPr algn="l"/>
                       <a:r>
-                        <a:rPr sz="1400" b="0">
+                        <a:rPr sz="1500" b="0">
                           <a:solidFill>
                             <a:srgbClr val="262B30"/>
                           </a:solidFill>
                           <a:latin typeface="Arial"/>
                         </a:rPr>
-                        <a:t>Points, missions, ranking; same points everywhere</a:t>
+                        <a:t>The same map, plus points, missions, a stamp rally, ranking and medals</a:t>
                       </a:r>
                     </a:p>
                   </a:txBody>
                   <a:tcPr marL="70000" marR="70000" marT="30000" marB="30000" anchor="ctr">
                     <a:solidFill>
                       <a:srgbClr val="E9F6F9"/>
-                    </a:solidFill>
-                  </a:tcPr>
-                </a:tc>
-                <a:tc>
-                  <a:txBody>
-                    <a:bodyPr wrap="square"/>
-                    <a:lstStyle/>
-                    <a:p>
-                      <a:pPr algn="l"/>
-                      <a:r>
-                        <a:rPr sz="1400" b="0">
-                          <a:solidFill>
-                            <a:srgbClr val="262B30"/>
-                          </a:solidFill>
-                          <a:latin typeface="Arial"/>
-                        </a:rPr>
-                        <a:t>Effect of gamification</a:t>
-                      </a:r>
-                    </a:p>
-                  </a:txBody>
-                  <a:tcPr marL="70000" marR="70000" marT="30000" marB="30000" anchor="ctr">
-                    <a:solidFill>
-                      <a:srgbClr val="E9F6F9"/>
-                    </a:solidFill>
-                  </a:tcPr>
-                </a:tc>
-              </a:tr>
-              <a:tr h="800000">
-                <a:tc>
-                  <a:txBody>
-                    <a:bodyPr wrap="square"/>
-                    <a:lstStyle/>
-                    <a:p>
-                      <a:pPr algn="l"/>
-                      <a:r>
-                        <a:rPr sz="1400" b="0">
-                          <a:solidFill>
-                            <a:srgbClr val="262B30"/>
-                          </a:solidFill>
-                          <a:latin typeface="Arial"/>
-                        </a:rPr>
-                        <a:t>Gamification + incentive</a:t>
-                      </a:r>
-                    </a:p>
-                  </a:txBody>
-                  <a:tcPr marL="70000" marR="70000" marT="30000" marB="30000" anchor="ctr">
-                    <a:solidFill>
-                      <a:srgbClr val="FFFFFF"/>
-                    </a:solidFill>
-                  </a:tcPr>
-                </a:tc>
-                <a:tc>
-                  <a:txBody>
-                    <a:bodyPr wrap="square"/>
-                    <a:lstStyle/>
-                    <a:p>
-                      <a:pPr algn="l"/>
-                      <a:r>
-                        <a:rPr sz="1400" b="0">
-                          <a:solidFill>
-                            <a:srgbClr val="262B30"/>
-                          </a:solidFill>
-                          <a:latin typeface="Arial"/>
-                        </a:rPr>
-                        <a:t>As above, plus extra points at less popular spots</a:t>
-                      </a:r>
-                    </a:p>
-                  </a:txBody>
-                  <a:tcPr marL="70000" marR="70000" marT="30000" marB="30000" anchor="ctr">
-                    <a:solidFill>
-                      <a:srgbClr val="FFFFFF"/>
-                    </a:solidFill>
-                  </a:tcPr>
-                </a:tc>
-                <a:tc>
-                  <a:txBody>
-                    <a:bodyPr wrap="square"/>
-                    <a:lstStyle/>
-                    <a:p>
-                      <a:pPr algn="l"/>
-                      <a:r>
-                        <a:rPr sz="1400" b="0">
-                          <a:solidFill>
-                            <a:srgbClr val="262B30"/>
-                          </a:solidFill>
-                          <a:latin typeface="Arial"/>
-                        </a:rPr>
-                        <a:t>Added effect of the incentive</a:t>
-                      </a:r>
-                    </a:p>
-                  </a:txBody>
-                  <a:tcPr marL="70000" marR="70000" marT="30000" marB="30000" anchor="ctr">
-                    <a:solidFill>
-                      <a:srgbClr val="FFFFFF"/>
                     </a:solidFill>
                   </a:tcPr>
                 </a:tc>
@@ -17033,8 +17823,8 @@
         </p:nvSpPr>
         <p:spPr>
           <a:xfrm>
-            <a:off x="900000" y="4780000"/>
-            <a:ext cx="7300000" cy="1800000"/>
+            <a:off x="900000" y="3730000"/>
+            <a:ext cx="7300000" cy="3200000"/>
           </a:xfrm>
           <a:prstGeom prst="rect">
             <a:avLst/>
@@ -17047,20 +17837,19 @@
           </a:bodyPr>
           <a:lstStyle/>
           <a:p>
-            <a:pPr algn="l" marL="228600" indent="-228600">
+            <a:pPr algn="l">
               <a:spcAft>
                 <a:spcPts val="600"/>
               </a:spcAft>
-              <a:buChar char="•"/>
             </a:pPr>
             <a:r>
-              <a:rPr sz="1700" b="0">
-                <a:solidFill>
-                  <a:srgbClr val="262B30"/>
+              <a:rPr sz="2000" b="1">
+                <a:solidFill>
+                  <a:srgbClr val="0F2F46"/>
                 </a:solidFill>
                 <a:latin typeface="Arial"/>
               </a:rPr>
-              <a:t>Three groups separate the effect of gamification from the effect of the incentive, matching the research question.</a:t>
+              <a:t>Only gamification differs</a:t>
             </a:r>
           </a:p>
           <a:p>
@@ -17071,13 +17860,22 @@
               <a:buChar char="•"/>
             </a:pPr>
             <a:r>
+              <a:rPr sz="1700" b="1">
+                <a:solidFill>
+                  <a:srgbClr val="262B30"/>
+                </a:solidFill>
+                <a:latin typeface="Arial"/>
+              </a:rPr>
+              <a:t>Equal rewards at every checkpoint: </a:t>
+            </a:r>
+            <a:r>
               <a:rPr sz="1700" b="0">
                 <a:solidFill>
                   <a:srgbClr val="262B30"/>
                 </a:solidFill>
                 <a:latin typeface="Arial"/>
               </a:rPr>
-              <a:t>Assign people randomly within each nationality group, so every group has a similar mix.</a:t>
+              <a:t>no extra points for less popular spots</a:t>
             </a:r>
           </a:p>
           <a:p>
@@ -17088,13 +17886,100 @@
               <a:buChar char="•"/>
             </a:pPr>
             <a:r>
+              <a:rPr sz="1700" b="1">
+                <a:solidFill>
+                  <a:srgbClr val="262B30"/>
+                </a:solidFill>
+                <a:latin typeface="Arial"/>
+              </a:rPr>
+              <a:t>Stamp rally of all 16 checkpoints: </a:t>
+            </a:r>
+            <a:r>
               <a:rPr sz="1700" b="0">
                 <a:solidFill>
                   <a:srgbClr val="262B30"/>
                 </a:solidFill>
                 <a:latin typeface="Arial"/>
               </a:rPr>
-              <a:t>If recruitment is limited, drop the middle group.</a:t>
+              <a:t>13 of 16 stamps are at less popular spots</a:t>
+            </a:r>
+          </a:p>
+          <a:p>
+            <a:pPr algn="l" marL="228600" indent="-228600">
+              <a:spcAft>
+                <a:spcPts val="600"/>
+              </a:spcAft>
+              <a:buChar char="•"/>
+            </a:pPr>
+            <a:r>
+              <a:rPr sz="1700" b="1">
+                <a:solidFill>
+                  <a:srgbClr val="262B30"/>
+                </a:solidFill>
+                <a:latin typeface="Arial"/>
+              </a:rPr>
+              <a:t>Same fee for everyone: </a:t>
+            </a:r>
+            <a:r>
+              <a:rPr sz="1700" b="0">
+                <a:solidFill>
+                  <a:srgbClr val="262B30"/>
+                </a:solidFill>
+                <a:latin typeface="Arial"/>
+              </a:rPr>
+              <a:t>no bonus by ranking</a:t>
+            </a:r>
+          </a:p>
+          <a:p>
+            <a:pPr algn="l" marL="228600" indent="-228600">
+              <a:spcAft>
+                <a:spcPts val="600"/>
+              </a:spcAft>
+              <a:buChar char="•"/>
+            </a:pPr>
+            <a:r>
+              <a:rPr sz="1700" b="1">
+                <a:solidFill>
+                  <a:srgbClr val="262B30"/>
+                </a:solidFill>
+                <a:latin typeface="Arial"/>
+              </a:rPr>
+              <a:t>Same measurement: </a:t>
+            </a:r>
+            <a:r>
+              <a:rPr sz="1700" b="0">
+                <a:solidFill>
+                  <a:srgbClr val="262B30"/>
+                </a:solidFill>
+                <a:latin typeface="Arial"/>
+              </a:rPr>
+              <a:t>automatic GPS check-in in both groups</a:t>
+            </a:r>
+          </a:p>
+          <a:p>
+            <a:pPr algn="l" marL="228600" indent="-228600">
+              <a:spcAft>
+                <a:spcPts val="600"/>
+              </a:spcAft>
+              <a:buChar char="•"/>
+            </a:pPr>
+            <a:r>
+              <a:rPr sz="1700" b="1">
+                <a:solidFill>
+                  <a:srgbClr val="262B30"/>
+                </a:solidFill>
+                <a:latin typeface="Arial"/>
+              </a:rPr>
+              <a:t>Random assignment </a:t>
+            </a:r>
+            <a:r>
+              <a:rPr sz="1700" b="0">
+                <a:solidFill>
+                  <a:srgbClr val="262B30"/>
+                </a:solidFill>
+                <a:latin typeface="Arial"/>
+              </a:rPr>
+              <a:t>within Japanese and foreign participants</a:t>
             </a:r>
           </a:p>
         </p:txBody>
@@ -17202,7 +18087,7 @@
                 </a:solidFill>
                 <a:latin typeface="Arial"/>
               </a:rPr>
-              <a:t>Large effect (d = 0.8), 2 groups</a:t>
+              <a:t>Large effect (d = 0.8)</a:t>
             </a:r>
           </a:p>
         </p:txBody>
@@ -17310,7 +18195,7 @@
                 </a:solidFill>
                 <a:latin typeface="Arial"/>
               </a:rPr>
-              <a:t>Medium effect (d = 0.5), 2 groups</a:t>
+              <a:t>Medium effect (d = 0.5)</a:t>
             </a:r>
           </a:p>
         </p:txBody>

</xml_diff>

<commit_message>
Use 15-20 participants per group and separate questionnaires in deck
Co-Authored-By: Claude Opus 5.5 <noreply@anthropic.com>
Claude-Session: https://claude.ai/code/session_01KouW72fBMSCT3ro1ARBkSw
</commit_message>
<xml_diff>
--- a/reports/Asakusa_progress_report.pptx
+++ b/reports/Asakusa_progress_report.pptx
@@ -9088,7 +9088,7 @@
                           </a:solidFill>
                           <a:latin typeface="Arial"/>
                         </a:rPr>
-                        <a:t>Poisson / neg. binomial regression</a:t>
+                        <a:t>Exploratory (descriptive only)</a:t>
                       </a:r>
                     </a:p>
                   </a:txBody>
@@ -9159,7 +9159,7 @@
                           </a:solidFill>
                           <a:latin typeface="Arial"/>
                         </a:rPr>
-                        <a:t>Post-survey satisfaction</a:t>
+                        <a:t>Post-questionnaire satisfaction</a:t>
                       </a:r>
                     </a:p>
                   </a:txBody>
@@ -9409,7 +9409,7 @@
                 <a:cs typeface="Arial"/>
                 <a:sym typeface="Arial"/>
               </a:rPr>
-              <a:t>Surveys and app changes</a:t>
+              <a:t>Questionnaires and app changes</a:t>
             </a:r>
             <a:endParaRPr/>
           </a:p>
@@ -9483,7 +9483,7 @@
           <a:p>
             <a:pPr algn="l">
               <a:spcAft>
-                <a:spcPts val="600"/>
+                <a:spcPts val="400"/>
               </a:spcAft>
             </a:pPr>
             <a:r>
@@ -9493,7 +9493,39 @@
                 </a:solidFill>
                 <a:latin typeface="Arial"/>
               </a:rPr>
-              <a:t>Pre-survey (in the app)</a:t>
+              <a:t>Questionnaires (separate from the app)</a:t>
+            </a:r>
+          </a:p>
+          <a:p>
+            <a:pPr algn="l">
+              <a:spcAft>
+                <a:spcPts val="1400"/>
+              </a:spcAft>
+            </a:pPr>
+            <a:r>
+              <a:rPr sz="1500" b="0">
+                <a:solidFill>
+                  <a:srgbClr val="5A646E"/>
+                </a:solidFill>
+                <a:latin typeface="Arial"/>
+              </a:rPr>
+              <a:t>Paper or online form, linked to app logs by participant ID</a:t>
+            </a:r>
+          </a:p>
+          <a:p>
+            <a:pPr algn="l">
+              <a:spcAft>
+                <a:spcPts val="600"/>
+              </a:spcAft>
+            </a:pPr>
+            <a:r>
+              <a:rPr sz="1800" b="1">
+                <a:solidFill>
+                  <a:srgbClr val="0F2F46"/>
+                </a:solidFill>
+                <a:latin typeface="Arial"/>
+              </a:rPr>
+              <a:t>Pre (before the walk)</a:t>
             </a:r>
           </a:p>
           <a:p>
@@ -9504,13 +9536,13 @@
               <a:buChar char="•"/>
             </a:pPr>
             <a:r>
-              <a:rPr sz="1700" b="0">
+              <a:rPr sz="1600" b="0">
                 <a:solidFill>
                   <a:srgbClr val="262B30"/>
                 </a:solidFill>
                 <a:latin typeface="Arial"/>
               </a:rPr>
-              <a:t>Add country of residence and nationality</a:t>
+              <a:t>Age, gender, nationality, country of residence</a:t>
             </a:r>
           </a:p>
           <a:p>
@@ -9521,30 +9553,30 @@
               <a:buChar char="•"/>
             </a:pPr>
             <a:r>
-              <a:rPr sz="1700" b="0">
+              <a:rPr sz="1600" b="0">
                 <a:solidFill>
                   <a:srgbClr val="262B30"/>
                 </a:solidFill>
                 <a:latin typeface="Arial"/>
               </a:rPr>
-              <a:t>Replace "visits to Yamanashi" with visits to Asakusa / Tokyo</a:t>
+              <a:t>Previous visits; checkpoints already known</a:t>
             </a:r>
           </a:p>
           <a:p>
             <a:pPr algn="l" marL="228600" indent="-228600">
               <a:spcAft>
-                <a:spcPts val="1600"/>
+                <a:spcPts val="1400"/>
               </a:spcAft>
               <a:buChar char="•"/>
             </a:pPr>
             <a:r>
-              <a:rPr sz="1700" b="0">
+              <a:rPr sz="1600" b="0">
                 <a:solidFill>
                   <a:srgbClr val="262B30"/>
                 </a:solidFill>
                 <a:latin typeface="Arial"/>
               </a:rPr>
-              <a:t>Add a motivation question (sightseeing, game or reward)</a:t>
+              <a:t>Travel motivation; experience with games and apps</a:t>
             </a:r>
           </a:p>
           <a:p>
@@ -9554,13 +9586,13 @@
               </a:spcAft>
             </a:pPr>
             <a:r>
-              <a:rPr sz="2000" b="1">
+              <a:rPr sz="1800" b="1">
                 <a:solidFill>
                   <a:srgbClr val="0F2F46"/>
                 </a:solidFill>
                 <a:latin typeface="Arial"/>
               </a:rPr>
-              <a:t>Post-survey (to build)</a:t>
+              <a:t>Post (right after the walk)</a:t>
             </a:r>
           </a:p>
           <a:p>
@@ -9571,13 +9603,13 @@
               <a:buChar char="•"/>
             </a:pPr>
             <a:r>
-              <a:rPr sz="1700" b="0">
+              <a:rPr sz="1600" b="0">
                 <a:solidFill>
                   <a:srgbClr val="262B30"/>
                 </a:solidFill>
                 <a:latin typeface="Arial"/>
               </a:rPr>
-              <a:t>Sightseeing vs mission priority (comparable with Kawanaka et al.)</a:t>
+              <a:t>Satisfaction, discovery of new places, perceived crowding, revisit intention</a:t>
             </a:r>
           </a:p>
           <a:p>
@@ -9588,13 +9620,13 @@
               <a:buChar char="•"/>
             </a:pPr>
             <a:r>
-              <a:rPr sz="1700" b="0">
+              <a:rPr sz="1600" b="0">
                 <a:solidFill>
                   <a:srgbClr val="262B30"/>
                 </a:solidFill>
                 <a:latin typeface="Arial"/>
               </a:rPr>
-              <a:t>Satisfaction, discovery of new places, perceived crowding</a:t>
+              <a:t>Why they chose the places they visited (free answer)</a:t>
             </a:r>
           </a:p>
           <a:p>
@@ -9605,13 +9637,13 @@
               <a:buChar char="•"/>
             </a:pPr>
             <a:r>
-              <a:rPr sz="1700" b="0">
+              <a:rPr sz="1600" b="0">
                 <a:solidFill>
                   <a:srgbClr val="262B30"/>
                 </a:solidFill>
                 <a:latin typeface="Arial"/>
               </a:rPr>
-              <a:t>Intention to revisit, free comment</a:t>
+              <a:t>Gamification group: which game features affected their route</a:t>
             </a:r>
           </a:p>
         </p:txBody>
@@ -9817,7 +9849,7 @@
                 </a:solidFill>
                 <a:latin typeface="Arial"/>
               </a:rPr>
-              <a:t>Tokyo survey text </a:t>
+              <a:t>Participant ID </a:t>
             </a:r>
             <a:r>
               <a:rPr sz="1700" b="0">
@@ -9826,7 +9858,7 @@
                 </a:solidFill>
                 <a:latin typeface="Arial"/>
               </a:rPr>
-              <a:t>in place of Yamanashi</a:t>
+              <a:t>at registration; no in-app survey changes needed</a:t>
             </a:r>
           </a:p>
         </p:txBody>
@@ -10103,7 +10135,7 @@
                 </a:solidFill>
                 <a:latin typeface="Arial"/>
               </a:rPr>
-              <a:t>Build the post-survey and update the pre-survey</a:t>
+              <a:t>Prepare the pre- and post-questionnaires</a:t>
             </a:r>
           </a:p>
           <a:p>
@@ -10285,7 +10317,7 @@
                 </a:solidFill>
                 <a:latin typeface="Arial"/>
               </a:rPr>
-              <a:t>2. What sample size can we realistically recruit (26 or 64 per group)?</a:t>
+              <a:t>2. Is 15–20 per group (30–40 total) acceptable as an exploratory study?</a:t>
             </a:r>
           </a:p>
           <a:p>
@@ -11403,7 +11435,7 @@
                 </a:solidFill>
                 <a:latin typeface="Arial"/>
               </a:rPr>
-              <a:t>Surveys and app changes</a:t>
+              <a:t>Questionnaires and app changes</a:t>
             </a:r>
           </a:p>
         </p:txBody>
@@ -17986,7 +18018,7 @@
       </p:sp>
       <p:sp>
         <p:nvSpPr>
-          <p:cNvPr id="55" name="Sample size 26"/>
+          <p:cNvPr id="55" name="Sample size 20"/>
           <p:cNvSpPr/>
           <p:nvPr/>
         </p:nvSpPr>
@@ -18062,7 +18094,7 @@
                 </a:solidFill>
                 <a:latin typeface="Arial"/>
               </a:rPr>
-              <a:t>26 </a:t>
+              <a:t>20 </a:t>
             </a:r>
             <a:r>
               <a:rPr sz="2800" b="0">
@@ -18087,14 +18119,14 @@
                 </a:solidFill>
                 <a:latin typeface="Arial"/>
               </a:rPr>
-              <a:t>Large effect (d = 0.8)</a:t>
+              <a:t>Planned: 40 total; detects d ≈ 0.9 (large)</a:t>
             </a:r>
           </a:p>
         </p:txBody>
       </p:sp>
       <p:sp>
         <p:nvSpPr>
-          <p:cNvPr id="57" name="Sample size 64"/>
+          <p:cNvPr id="57" name="Sample size 15"/>
           <p:cNvSpPr/>
           <p:nvPr/>
         </p:nvSpPr>
@@ -18170,7 +18202,7 @@
                 </a:solidFill>
                 <a:latin typeface="Arial"/>
               </a:rPr>
-              <a:t>64 </a:t>
+              <a:t>15 </a:t>
             </a:r>
             <a:r>
               <a:rPr sz="2800" b="0">
@@ -18195,7 +18227,7 @@
                 </a:solidFill>
                 <a:latin typeface="Arial"/>
               </a:rPr>
-              <a:t>Medium effect (d = 0.5)</a:t>
+              <a:t>Minimum: 30 total; detects d ≈ 1.1 (very large)</a:t>
             </a:r>
           </a:p>
         </p:txBody>
@@ -18342,7 +18374,7 @@
                 </a:solidFill>
                 <a:latin typeface="Arial"/>
               </a:rPr>
-              <a:t>α = 0.05, power = 0.80; to be confirmed with G*Power.</a:t>
+              <a:t>α = 0.05, power = 0.80; to be confirmed with G*Power. Small sample, so results are exploratory.</a:t>
             </a:r>
           </a:p>
         </p:txBody>

</xml_diff>